<commit_message>
Fill in NIM, GitHub link, and original Google Sheet URL
Co-Authored-By: Claude Sonnet 5 <noreply@anthropic.com>
</commit_message>
<xml_diff>
--- a/Assignment 1 - SLP - Muhammad Javier.pptx
+++ b/Assignment 1 - SLP - Muhammad Javier.pptx
@@ -6906,7 +6906,7 @@
                 </a:solidFill>
                 <a:latin typeface="Gama-Sans-Regular"/>
               </a:rPr>
-              <a:t>{{NIM}}</a:t>
+              <a:t>24/546674/PA/23210</a:t>
             </a:r>
           </a:p>
           <a:p>
@@ -8838,7 +8838,7 @@
                 <a:latin typeface="Gama-Sans-Regular"/>
                 <a:hlinkClick r:id="rId2"/>
               </a:rPr>
-              <a:t>https://docs.google.com/spreadsheets/d/1yhi8ASebpmljJ3NpYQ7NmxlWLmhGOI6W/edit?gid=1211907647#gid=1211907647</a:t>
+              <a:t>https://docs.google.com/spreadsheets/d/1zPx4ckdLXXAYSfJ87rMhDIB8mPoLJA7x/edit?usp=sharing&amp;ouid=118399330202018473068&amp;rtpof=true&amp;sd=true</a:t>
             </a:r>
           </a:p>
         </p:txBody>
@@ -9001,8 +9001,9 @@
                   <a:srgbClr val="0E426B"/>
                 </a:solidFill>
                 <a:latin typeface="Gama-Sans-Regular"/>
-              </a:rPr>
-              <a:t>{{GITHUB_REPO_URL}}</a:t>
+                <a:hlinkClick r:id="rId3"/>
+              </a:rPr>
+              <a:t>https://github.com/muhajav/SLP-Deep-Learning</a:t>
             </a:r>
           </a:p>
         </p:txBody>

</xml_diff>

<commit_message>
Switch to the separated training and validation worksheets
The lecturer split the workbook into two sheets, and the training block now
carries the real Iris petal widths throughout.

- Read from SLP-training-new.csv and SLP-validation-new.csv, dropping the old
  combined export and the earlier validation template
- Map each epoch's block offset explicitly, since the two sheets use different
  row strides between epochs
- Verified cell-for-cell against every bias, z, g(z) and SSE value in the two
  epochs the sheets currently have filled: zero mismatches
- Rebuild the four charts and the deck against the new numbers
- sheet-fill-block.csv now covers what is still empty: the starting weights for
  training epochs 3-5, the constant weights for validation epochs 3-5, and the
  per-epoch metrics neither sheet computes yet

Validation accuracy reaches 100% at epoch 5, training 98.75%, training loss
0.012740.

Co-Authored-By: Claude Opus 5 <noreply@anthropic.com>
</commit_message>
<xml_diff>
--- a/Assignment 1 - SLP - Muhammad Javier.pptx
+++ b/Assignment 1 - SLP - Muhammad Javier.pptx
@@ -7693,7 +7693,7 @@
                 </a:solidFill>
                 <a:latin typeface="Gama-Sans-Regular"/>
               </a:rPr>
-              <a:t>Training vs validation accuracy per epoch, computed in the SLP spreadsheet (80 training / 20 validation samples).</a:t>
+              <a:t>Per-epoch accuracy from the two worksheets: 80 training samples, and the 20 held-out samples scored on the weights each epoch ends with.</a:t>
             </a:r>
           </a:p>
         </p:txBody>
@@ -7759,7 +7759,7 @@
                 </a:solidFill>
                 <a:latin typeface="Gama-Sans-Regular"/>
               </a:rPr>
-              <a:t>Training accuracy rises 52.50% → 98.75%. Validation sits at 50.00% while the boundary is still separating on sepal size, then reaches 85.00% at epoch 4 and 100.00% at epoch 5 as the petal weights take over.</a:t>
+              <a:t>Training accuracy rises 52.50% → 98.75%. Validation sits at 50.00% while the boundary still leans on sepal size, then reaches 85.00% at epoch 4 and 100.00% at epoch 5 as the petal weights take over.</a:t>
             </a:r>
           </a:p>
         </p:txBody>
@@ -8183,7 +8183,7 @@
                 </a:solidFill>
                 <a:latin typeface="Gama-Sans-Regular"/>
               </a:rPr>
-              <a:t>Mean Sum-Square-Error per epoch. Validation reuses the bias and teta that training ends each epoch with, exactly as the worksheet specifies.</a:t>
+              <a:t>Mean Sum-Square-Error per epoch. Validation reuses the bias and teta that training ends each epoch on, exactly as the worksheet specifies.</a:t>
             </a:r>
           </a:p>
         </p:txBody>
@@ -8249,7 +8249,7 @@
                 </a:solidFill>
                 <a:latin typeface="Gama-Sans-Regular"/>
               </a:rPr>
-              <a:t>Training loss falls 0.450203 → 0.012764, the steepest drop in epoch 2. Validation loss decreases steadily 0.329163 → 0.081583 — it never turns upward, so there is no overfitting across these five epochs.</a:t>
+              <a:t>Training loss falls 0.449889 → 0.012740, the steepest drop in epoch 2. Validation loss decreases steadily 0.328951 → 0.081581 — it never turns upward, so there is no overfitting across these five epochs.</a:t>
             </a:r>
           </a:p>
         </p:txBody>
@@ -8494,7 +8494,7 @@
                 </a:solidFill>
                 <a:latin typeface="Gama-Sans-Regular"/>
               </a:rPr>
-              <a:t>Training loss reproduces the spreadsheet's Sum-Square-Error column exactly — 0.4502033345, 0.0375290227, 0.0244179422, 0.0173886874, 0.0127640598 — confirming both implementations follow the same update rule.</a:t>
+              <a:t>Training loss reproduces the worksheet's Sum-Square-Error column exactly — 0.4498886551, 0.0374519142, 0.0243721950, 0.0173572017, 0.0127401582 — confirming both implementations follow the same update rule.</a:t>
             </a:r>
           </a:p>
         </p:txBody>
@@ -8795,7 +8795,7 @@
                 </a:solidFill>
                 <a:latin typeface="Gama-Sans-Regular"/>
               </a:rPr>
-              <a:t>Task 1 — SLP worksheet, 5 epochs, 80 training / 20 validation samples</a:t>
+              <a:t>Task 1 — SLP training and validation worksheets, 5 epochs, 80 training / 20 validation samples</a:t>
             </a:r>
           </a:p>
         </p:txBody>

</xml_diff>